<commit_message>
Initial commit: Student Success AI/ML project
</commit_message>
<xml_diff>
--- a/student_success_early_warning_system/student_success_warning_system.pptx
+++ b/student_success_early_warning_system/student_success_warning_system.pptx
@@ -168,10 +168,9 @@
           <a:lstStyle/>
           <a:p>
             <a:r>
-              <a:rPr lang="en-US" smtClean="0"/>
+              <a:rPr lang="en-US"/>
               <a:t>Click to edit Master title style</a:t>
             </a:r>
-            <a:endParaRPr lang="en-US"/>
           </a:p>
         </p:txBody>
       </p:sp>
@@ -287,10 +286,9 @@
           </a:lstStyle>
           <a:p>
             <a:r>
-              <a:rPr lang="en-US" smtClean="0"/>
+              <a:rPr lang="en-US"/>
               <a:t>Click to edit Master subtitle style</a:t>
             </a:r>
-            <a:endParaRPr lang="en-US"/>
           </a:p>
         </p:txBody>
       </p:sp>
@@ -405,10 +403,9 @@
           <a:lstStyle/>
           <a:p>
             <a:r>
-              <a:rPr lang="en-US" smtClean="0"/>
+              <a:rPr lang="en-US"/>
               <a:t>Click to edit Master title style</a:t>
             </a:r>
-            <a:endParaRPr lang="en-US"/>
           </a:p>
         </p:txBody>
       </p:sp>
@@ -429,38 +426,37 @@
           <a:p>
             <a:pPr lvl="0"/>
             <a:r>
-              <a:rPr lang="en-US" smtClean="0"/>
+              <a:rPr lang="en-US"/>
               <a:t>Click to edit Master text styles</a:t>
             </a:r>
           </a:p>
           <a:p>
             <a:pPr lvl="1"/>
             <a:r>
-              <a:rPr lang="en-US" smtClean="0"/>
+              <a:rPr lang="en-US"/>
               <a:t>Second level</a:t>
             </a:r>
           </a:p>
           <a:p>
             <a:pPr lvl="2"/>
             <a:r>
-              <a:rPr lang="en-US" smtClean="0"/>
+              <a:rPr lang="en-US"/>
               <a:t>Third level</a:t>
             </a:r>
           </a:p>
           <a:p>
             <a:pPr lvl="3"/>
             <a:r>
-              <a:rPr lang="en-US" smtClean="0"/>
+              <a:rPr lang="en-US"/>
               <a:t>Fourth level</a:t>
             </a:r>
           </a:p>
           <a:p>
             <a:pPr lvl="4"/>
             <a:r>
-              <a:rPr lang="en-US" smtClean="0"/>
+              <a:rPr lang="en-US"/>
               <a:t>Fifth level</a:t>
             </a:r>
-            <a:endParaRPr lang="en-US"/>
           </a:p>
         </p:txBody>
       </p:sp>
@@ -580,10 +576,9 @@
           <a:lstStyle/>
           <a:p>
             <a:r>
-              <a:rPr lang="en-US" smtClean="0"/>
+              <a:rPr lang="en-US"/>
               <a:t>Click to edit Master title style</a:t>
             </a:r>
-            <a:endParaRPr lang="en-US"/>
           </a:p>
         </p:txBody>
       </p:sp>
@@ -609,38 +604,37 @@
           <a:p>
             <a:pPr lvl="0"/>
             <a:r>
-              <a:rPr lang="en-US" smtClean="0"/>
+              <a:rPr lang="en-US"/>
               <a:t>Click to edit Master text styles</a:t>
             </a:r>
           </a:p>
           <a:p>
             <a:pPr lvl="1"/>
             <a:r>
-              <a:rPr lang="en-US" smtClean="0"/>
+              <a:rPr lang="en-US"/>
               <a:t>Second level</a:t>
             </a:r>
           </a:p>
           <a:p>
             <a:pPr lvl="2"/>
             <a:r>
-              <a:rPr lang="en-US" smtClean="0"/>
+              <a:rPr lang="en-US"/>
               <a:t>Third level</a:t>
             </a:r>
           </a:p>
           <a:p>
             <a:pPr lvl="3"/>
             <a:r>
-              <a:rPr lang="en-US" smtClean="0"/>
+              <a:rPr lang="en-US"/>
               <a:t>Fourth level</a:t>
             </a:r>
           </a:p>
           <a:p>
             <a:pPr lvl="4"/>
             <a:r>
-              <a:rPr lang="en-US" smtClean="0"/>
+              <a:rPr lang="en-US"/>
               <a:t>Fifth level</a:t>
             </a:r>
-            <a:endParaRPr lang="en-US"/>
           </a:p>
         </p:txBody>
       </p:sp>
@@ -755,10 +749,9 @@
           <a:lstStyle/>
           <a:p>
             <a:r>
-              <a:rPr lang="en-US" smtClean="0"/>
+              <a:rPr lang="en-US"/>
               <a:t>Click to edit Master title style</a:t>
             </a:r>
-            <a:endParaRPr lang="en-US"/>
           </a:p>
         </p:txBody>
       </p:sp>
@@ -779,38 +772,37 @@
           <a:p>
             <a:pPr lvl="0"/>
             <a:r>
-              <a:rPr lang="en-US" smtClean="0"/>
+              <a:rPr lang="en-US"/>
               <a:t>Click to edit Master text styles</a:t>
             </a:r>
           </a:p>
           <a:p>
             <a:pPr lvl="1"/>
             <a:r>
-              <a:rPr lang="en-US" smtClean="0"/>
+              <a:rPr lang="en-US"/>
               <a:t>Second level</a:t>
             </a:r>
           </a:p>
           <a:p>
             <a:pPr lvl="2"/>
             <a:r>
-              <a:rPr lang="en-US" smtClean="0"/>
+              <a:rPr lang="en-US"/>
               <a:t>Third level</a:t>
             </a:r>
           </a:p>
           <a:p>
             <a:pPr lvl="3"/>
             <a:r>
-              <a:rPr lang="en-US" smtClean="0"/>
+              <a:rPr lang="en-US"/>
               <a:t>Fourth level</a:t>
             </a:r>
           </a:p>
           <a:p>
             <a:pPr lvl="4"/>
             <a:r>
-              <a:rPr lang="en-US" smtClean="0"/>
+              <a:rPr lang="en-US"/>
               <a:t>Fifth level</a:t>
             </a:r>
-            <a:endParaRPr lang="en-US"/>
           </a:p>
         </p:txBody>
       </p:sp>
@@ -934,10 +926,9 @@
           </a:lstStyle>
           <a:p>
             <a:r>
-              <a:rPr lang="en-US" smtClean="0"/>
+              <a:rPr lang="en-US"/>
               <a:t>Click to edit Master title style</a:t>
             </a:r>
-            <a:endParaRPr lang="en-US"/>
           </a:p>
         </p:txBody>
       </p:sp>
@@ -1054,7 +1045,7 @@
           <a:p>
             <a:pPr lvl="0"/>
             <a:r>
-              <a:rPr lang="en-US" smtClean="0"/>
+              <a:rPr lang="en-US"/>
               <a:t>Click to edit Master text styles</a:t>
             </a:r>
           </a:p>
@@ -1171,10 +1162,9 @@
           <a:lstStyle/>
           <a:p>
             <a:r>
-              <a:rPr lang="en-US" smtClean="0"/>
+              <a:rPr lang="en-US"/>
               <a:t>Click to edit Master title style</a:t>
             </a:r>
-            <a:endParaRPr lang="en-US"/>
           </a:p>
         </p:txBody>
       </p:sp>
@@ -1228,38 +1218,37 @@
           <a:p>
             <a:pPr lvl="0"/>
             <a:r>
-              <a:rPr lang="en-US" smtClean="0"/>
+              <a:rPr lang="en-US"/>
               <a:t>Click to edit Master text styles</a:t>
             </a:r>
           </a:p>
           <a:p>
             <a:pPr lvl="1"/>
             <a:r>
-              <a:rPr lang="en-US" smtClean="0"/>
+              <a:rPr lang="en-US"/>
               <a:t>Second level</a:t>
             </a:r>
           </a:p>
           <a:p>
             <a:pPr lvl="2"/>
             <a:r>
-              <a:rPr lang="en-US" smtClean="0"/>
+              <a:rPr lang="en-US"/>
               <a:t>Third level</a:t>
             </a:r>
           </a:p>
           <a:p>
             <a:pPr lvl="3"/>
             <a:r>
-              <a:rPr lang="en-US" smtClean="0"/>
+              <a:rPr lang="en-US"/>
               <a:t>Fourth level</a:t>
             </a:r>
           </a:p>
           <a:p>
             <a:pPr lvl="4"/>
             <a:r>
-              <a:rPr lang="en-US" smtClean="0"/>
+              <a:rPr lang="en-US"/>
               <a:t>Fifth level</a:t>
             </a:r>
-            <a:endParaRPr lang="en-US"/>
           </a:p>
         </p:txBody>
       </p:sp>
@@ -1313,38 +1302,37 @@
           <a:p>
             <a:pPr lvl="0"/>
             <a:r>
-              <a:rPr lang="en-US" smtClean="0"/>
+              <a:rPr lang="en-US"/>
               <a:t>Click to edit Master text styles</a:t>
             </a:r>
           </a:p>
           <a:p>
             <a:pPr lvl="1"/>
             <a:r>
-              <a:rPr lang="en-US" smtClean="0"/>
+              <a:rPr lang="en-US"/>
               <a:t>Second level</a:t>
             </a:r>
           </a:p>
           <a:p>
             <a:pPr lvl="2"/>
             <a:r>
-              <a:rPr lang="en-US" smtClean="0"/>
+              <a:rPr lang="en-US"/>
               <a:t>Third level</a:t>
             </a:r>
           </a:p>
           <a:p>
             <a:pPr lvl="3"/>
             <a:r>
-              <a:rPr lang="en-US" smtClean="0"/>
+              <a:rPr lang="en-US"/>
               <a:t>Fourth level</a:t>
             </a:r>
           </a:p>
           <a:p>
             <a:pPr lvl="4"/>
             <a:r>
-              <a:rPr lang="en-US" smtClean="0"/>
+              <a:rPr lang="en-US"/>
               <a:t>Fifth level</a:t>
             </a:r>
-            <a:endParaRPr lang="en-US"/>
           </a:p>
         </p:txBody>
       </p:sp>
@@ -1463,10 +1451,9 @@
           </a:lstStyle>
           <a:p>
             <a:r>
-              <a:rPr lang="en-US" smtClean="0"/>
+              <a:rPr lang="en-US"/>
               <a:t>Click to edit Master title style</a:t>
             </a:r>
-            <a:endParaRPr lang="en-US"/>
           </a:p>
         </p:txBody>
       </p:sp>
@@ -1529,7 +1516,7 @@
           <a:p>
             <a:pPr lvl="0"/>
             <a:r>
-              <a:rPr lang="en-US" smtClean="0"/>
+              <a:rPr lang="en-US"/>
               <a:t>Click to edit Master text styles</a:t>
             </a:r>
           </a:p>
@@ -1585,38 +1572,37 @@
           <a:p>
             <a:pPr lvl="0"/>
             <a:r>
-              <a:rPr lang="en-US" smtClean="0"/>
+              <a:rPr lang="en-US"/>
               <a:t>Click to edit Master text styles</a:t>
             </a:r>
           </a:p>
           <a:p>
             <a:pPr lvl="1"/>
             <a:r>
-              <a:rPr lang="en-US" smtClean="0"/>
+              <a:rPr lang="en-US"/>
               <a:t>Second level</a:t>
             </a:r>
           </a:p>
           <a:p>
             <a:pPr lvl="2"/>
             <a:r>
-              <a:rPr lang="en-US" smtClean="0"/>
+              <a:rPr lang="en-US"/>
               <a:t>Third level</a:t>
             </a:r>
           </a:p>
           <a:p>
             <a:pPr lvl="3"/>
             <a:r>
-              <a:rPr lang="en-US" smtClean="0"/>
+              <a:rPr lang="en-US"/>
               <a:t>Fourth level</a:t>
             </a:r>
           </a:p>
           <a:p>
             <a:pPr lvl="4"/>
             <a:r>
-              <a:rPr lang="en-US" smtClean="0"/>
+              <a:rPr lang="en-US"/>
               <a:t>Fifth level</a:t>
             </a:r>
-            <a:endParaRPr lang="en-US"/>
           </a:p>
         </p:txBody>
       </p:sp>
@@ -1679,7 +1665,7 @@
           <a:p>
             <a:pPr lvl="0"/>
             <a:r>
-              <a:rPr lang="en-US" smtClean="0"/>
+              <a:rPr lang="en-US"/>
               <a:t>Click to edit Master text styles</a:t>
             </a:r>
           </a:p>
@@ -1735,38 +1721,37 @@
           <a:p>
             <a:pPr lvl="0"/>
             <a:r>
-              <a:rPr lang="en-US" smtClean="0"/>
+              <a:rPr lang="en-US"/>
               <a:t>Click to edit Master text styles</a:t>
             </a:r>
           </a:p>
           <a:p>
             <a:pPr lvl="1"/>
             <a:r>
-              <a:rPr lang="en-US" smtClean="0"/>
+              <a:rPr lang="en-US"/>
               <a:t>Second level</a:t>
             </a:r>
           </a:p>
           <a:p>
             <a:pPr lvl="2"/>
             <a:r>
-              <a:rPr lang="en-US" smtClean="0"/>
+              <a:rPr lang="en-US"/>
               <a:t>Third level</a:t>
             </a:r>
           </a:p>
           <a:p>
             <a:pPr lvl="3"/>
             <a:r>
-              <a:rPr lang="en-US" smtClean="0"/>
+              <a:rPr lang="en-US"/>
               <a:t>Fourth level</a:t>
             </a:r>
           </a:p>
           <a:p>
             <a:pPr lvl="4"/>
             <a:r>
-              <a:rPr lang="en-US" smtClean="0"/>
+              <a:rPr lang="en-US"/>
               <a:t>Fifth level</a:t>
             </a:r>
-            <a:endParaRPr lang="en-US"/>
           </a:p>
         </p:txBody>
       </p:sp>
@@ -1881,10 +1866,9 @@
           <a:lstStyle/>
           <a:p>
             <a:r>
-              <a:rPr lang="en-US" smtClean="0"/>
+              <a:rPr lang="en-US"/>
               <a:t>Click to edit Master title style</a:t>
             </a:r>
-            <a:endParaRPr lang="en-US"/>
           </a:p>
         </p:txBody>
       </p:sp>
@@ -2103,10 +2087,9 @@
           </a:lstStyle>
           <a:p>
             <a:r>
-              <a:rPr lang="en-US" smtClean="0"/>
+              <a:rPr lang="en-US"/>
               <a:t>Click to edit Master title style</a:t>
             </a:r>
-            <a:endParaRPr lang="en-US"/>
           </a:p>
         </p:txBody>
       </p:sp>
@@ -2160,38 +2143,37 @@
           <a:p>
             <a:pPr lvl="0"/>
             <a:r>
-              <a:rPr lang="en-US" smtClean="0"/>
+              <a:rPr lang="en-US"/>
               <a:t>Click to edit Master text styles</a:t>
             </a:r>
           </a:p>
           <a:p>
             <a:pPr lvl="1"/>
             <a:r>
-              <a:rPr lang="en-US" smtClean="0"/>
+              <a:rPr lang="en-US"/>
               <a:t>Second level</a:t>
             </a:r>
           </a:p>
           <a:p>
             <a:pPr lvl="2"/>
             <a:r>
-              <a:rPr lang="en-US" smtClean="0"/>
+              <a:rPr lang="en-US"/>
               <a:t>Third level</a:t>
             </a:r>
           </a:p>
           <a:p>
             <a:pPr lvl="3"/>
             <a:r>
-              <a:rPr lang="en-US" smtClean="0"/>
+              <a:rPr lang="en-US"/>
               <a:t>Fourth level</a:t>
             </a:r>
           </a:p>
           <a:p>
             <a:pPr lvl="4"/>
             <a:r>
-              <a:rPr lang="en-US" smtClean="0"/>
+              <a:rPr lang="en-US"/>
               <a:t>Fifth level</a:t>
             </a:r>
-            <a:endParaRPr lang="en-US"/>
           </a:p>
         </p:txBody>
       </p:sp>
@@ -2254,7 +2236,7 @@
           <a:p>
             <a:pPr lvl="0"/>
             <a:r>
-              <a:rPr lang="en-US" smtClean="0"/>
+              <a:rPr lang="en-US"/>
               <a:t>Click to edit Master text styles</a:t>
             </a:r>
           </a:p>
@@ -2380,10 +2362,9 @@
           </a:lstStyle>
           <a:p>
             <a:r>
-              <a:rPr lang="en-US" smtClean="0"/>
+              <a:rPr lang="en-US"/>
               <a:t>Click to edit Master title style</a:t>
             </a:r>
-            <a:endParaRPr lang="en-US"/>
           </a:p>
         </p:txBody>
       </p:sp>
@@ -2507,7 +2488,7 @@
           <a:p>
             <a:pPr lvl="0"/>
             <a:r>
-              <a:rPr lang="en-US" smtClean="0"/>
+              <a:rPr lang="en-US"/>
               <a:t>Click to edit Master text styles</a:t>
             </a:r>
           </a:p>
@@ -2639,10 +2620,9 @@
           <a:lstStyle/>
           <a:p>
             <a:r>
-              <a:rPr lang="en-US" smtClean="0"/>
+              <a:rPr lang="en-US"/>
               <a:t>Click to edit Master title style</a:t>
             </a:r>
-            <a:endParaRPr lang="en-US"/>
           </a:p>
         </p:txBody>
       </p:sp>
@@ -2673,38 +2653,37 @@
           <a:p>
             <a:pPr lvl="0"/>
             <a:r>
-              <a:rPr lang="en-US" smtClean="0"/>
+              <a:rPr lang="en-US"/>
               <a:t>Click to edit Master text styles</a:t>
             </a:r>
           </a:p>
           <a:p>
             <a:pPr lvl="1"/>
             <a:r>
-              <a:rPr lang="en-US" smtClean="0"/>
+              <a:rPr lang="en-US"/>
               <a:t>Second level</a:t>
             </a:r>
           </a:p>
           <a:p>
             <a:pPr lvl="2"/>
             <a:r>
-              <a:rPr lang="en-US" smtClean="0"/>
+              <a:rPr lang="en-US"/>
               <a:t>Third level</a:t>
             </a:r>
           </a:p>
           <a:p>
             <a:pPr lvl="3"/>
             <a:r>
-              <a:rPr lang="en-US" smtClean="0"/>
+              <a:rPr lang="en-US"/>
               <a:t>Fourth level</a:t>
             </a:r>
           </a:p>
           <a:p>
             <a:pPr lvl="4"/>
             <a:r>
-              <a:rPr lang="en-US" smtClean="0"/>
+              <a:rPr lang="en-US"/>
               <a:t>Fifth level</a:t>
             </a:r>
-            <a:endParaRPr lang="en-US"/>
           </a:p>
         </p:txBody>
       </p:sp>
@@ -3157,7 +3136,7 @@
               </a:defRPr>
             </a:pPr>
             <a:r>
-              <a:rPr lang="en-IN" dirty="0" smtClean="0"/>
+              <a:rPr lang="en-IN" dirty="0"/>
               <a:t>Student Success Early Warning System</a:t>
             </a:r>
             <a:endParaRPr dirty="0"/>
@@ -3231,9 +3210,14 @@
               </a:defRPr>
             </a:pPr>
             <a:r>
-              <a:rPr lang="en-GB" dirty="0" smtClean="0"/>
-              <a:t>Bharat Salunke</a:t>
-            </a:r>
+              <a:rPr lang="en-GB" dirty="0"/>
+              <a:t>Jayesh </a:t>
+            </a:r>
+            <a:r>
+              <a:rPr lang="en-GB" dirty="0" err="1"/>
+              <a:t>Dabhade</a:t>
+            </a:r>
+            <a:endParaRPr lang="en-GB" dirty="0"/>
           </a:p>
           <a:p>
             <a:pPr algn="l">
@@ -3279,24 +3263,20 @@
               </a:defRPr>
             </a:pPr>
             <a:r>
-              <a:rPr lang="en-GB" dirty="0" smtClean="0"/>
+              <a:rPr lang="en-GB" dirty="0"/>
               <a:t> IBM </a:t>
             </a:r>
             <a:r>
-              <a:rPr lang="en-GB" dirty="0" err="1" smtClean="0"/>
+              <a:rPr lang="en-GB" dirty="0" err="1"/>
               <a:t>Skillbuild</a:t>
             </a:r>
             <a:r>
-              <a:rPr lang="en-GB" dirty="0" smtClean="0"/>
+              <a:rPr lang="en-GB" dirty="0"/>
               <a:t> </a:t>
             </a:r>
             <a:r>
-              <a:rPr dirty="0" smtClean="0"/>
-              <a:t>Applied </a:t>
-            </a:r>
-            <a:r>
               <a:rPr dirty="0"/>
-              <a:t>AI Internship</a:t>
+              <a:t>Applied AI Internship</a:t>
             </a:r>
           </a:p>
         </p:txBody>
@@ -3695,17 +3675,11 @@
               <a:t>Educational prototype</a:t>
             </a:r>
             <a:br/>
-            <a:r>
-              <a:t/>
-            </a:r>
             <a:br/>
             <a:r>
               <a:t>Not a clinical or psychological diagnosis.</a:t>
             </a:r>
             <a:br/>
-            <a:r>
-              <a:t/>
-            </a:r>
             <a:br/>
             <a:r>
               <a:t>Does not replace teachers or guarantee outcomes.</a:t>
@@ -5011,9 +4985,6 @@
               <a:t>G1 and G2 are valid when prior-term grades exist.</a:t>
             </a:r>
             <a:br/>
-            <a:r>
-              <a:t/>
-            </a:r>
             <a:br/>
             <a:r>
               <a:t>A second scenario excludes them for earlier prediction.</a:t>
@@ -5173,10 +5144,34 @@
                 <a:tableStyleId>{5C22544A-7EE6-4342-B048-85BDC9FD1C3A}</a:tableStyleId>
               </a:tblPr>
               <a:tblGrid>
-                <a:gridCol w="1600200"/>
-                <a:gridCol w="1600200"/>
-                <a:gridCol w="1600200"/>
-                <a:gridCol w="1600200"/>
+                <a:gridCol w="1600200">
+                  <a:extLst>
+                    <a:ext uri="{9D8B030D-6E8A-4147-A177-3AD203B41FA5}">
+                      <a16:colId xmlns:a16="http://schemas.microsoft.com/office/drawing/2014/main" val="20000"/>
+                    </a:ext>
+                  </a:extLst>
+                </a:gridCol>
+                <a:gridCol w="1600200">
+                  <a:extLst>
+                    <a:ext uri="{9D8B030D-6E8A-4147-A177-3AD203B41FA5}">
+                      <a16:colId xmlns:a16="http://schemas.microsoft.com/office/drawing/2014/main" val="20001"/>
+                    </a:ext>
+                  </a:extLst>
+                </a:gridCol>
+                <a:gridCol w="1600200">
+                  <a:extLst>
+                    <a:ext uri="{9D8B030D-6E8A-4147-A177-3AD203B41FA5}">
+                      <a16:colId xmlns:a16="http://schemas.microsoft.com/office/drawing/2014/main" val="20002"/>
+                    </a:ext>
+                  </a:extLst>
+                </a:gridCol>
+                <a:gridCol w="1600200">
+                  <a:extLst>
+                    <a:ext uri="{9D8B030D-6E8A-4147-A177-3AD203B41FA5}">
+                      <a16:colId xmlns:a16="http://schemas.microsoft.com/office/drawing/2014/main" val="20003"/>
+                    </a:ext>
+                  </a:extLst>
+                </a:gridCol>
               </a:tblGrid>
               <a:tr h="548640">
                 <a:tc>
@@ -5275,6 +5270,11 @@
                     </a:solidFill>
                   </a:tcPr>
                 </a:tc>
+                <a:extLst>
+                  <a:ext uri="{0D108BD9-81ED-4DB2-BD59-A6C34878D82A}">
+                    <a16:rowId xmlns:a16="http://schemas.microsoft.com/office/drawing/2014/main" val="10000"/>
+                  </a:ext>
+                </a:extLst>
               </a:tr>
               <a:tr h="548640">
                 <a:tc>
@@ -5357,6 +5357,11 @@
                   </a:txBody>
                   <a:tcPr/>
                 </a:tc>
+                <a:extLst>
+                  <a:ext uri="{0D108BD9-81ED-4DB2-BD59-A6C34878D82A}">
+                    <a16:rowId xmlns:a16="http://schemas.microsoft.com/office/drawing/2014/main" val="10001"/>
+                  </a:ext>
+                </a:extLst>
               </a:tr>
               <a:tr h="548640">
                 <a:tc>
@@ -5439,6 +5444,11 @@
                   </a:txBody>
                   <a:tcPr/>
                 </a:tc>
+                <a:extLst>
+                  <a:ext uri="{0D108BD9-81ED-4DB2-BD59-A6C34878D82A}">
+                    <a16:rowId xmlns:a16="http://schemas.microsoft.com/office/drawing/2014/main" val="10002"/>
+                  </a:ext>
+                </a:extLst>
               </a:tr>
               <a:tr h="548640">
                 <a:tc>
@@ -5521,6 +5531,11 @@
                   </a:txBody>
                   <a:tcPr/>
                 </a:tc>
+                <a:extLst>
+                  <a:ext uri="{0D108BD9-81ED-4DB2-BD59-A6C34878D82A}">
+                    <a16:rowId xmlns:a16="http://schemas.microsoft.com/office/drawing/2014/main" val="10003"/>
+                  </a:ext>
+                </a:extLst>
               </a:tr>
               <a:tr h="548640">
                 <a:tc>
@@ -5603,6 +5618,11 @@
                   </a:txBody>
                   <a:tcPr/>
                 </a:tc>
+                <a:extLst>
+                  <a:ext uri="{0D108BD9-81ED-4DB2-BD59-A6C34878D82A}">
+                    <a16:rowId xmlns:a16="http://schemas.microsoft.com/office/drawing/2014/main" val="10004"/>
+                  </a:ext>
+                </a:extLst>
               </a:tr>
             </a:tbl>
           </a:graphicData>
@@ -5724,9 +5744,6 @@
               <a:t>Gradient Boosting</a:t>
             </a:r>
             <a:br/>
-            <a:r>
-              <a:t/>
-            </a:r>
             <a:br/>
             <a:r>
               <a:t>MAE: 1.128</a:t>

</xml_diff>